<commit_message>
Agrega módulo de Puntos, mejoras al Dashboard y Gestión de solicitudes
- Módulo de Puntos de entrenamiento (backend NestJS + CRUD frontend) y
  asignación de lugar/entrenamiento a publicadores (acciones-bar, panel de
  asignación, mensajería asociada).
- Dashboard: filtro por Congregación, tabla expandible de resumen por
  circuito/congregación/publicador con exportación a PDF.
- Gestión de solicitudes: filtro de lista de chequeo por tipo/fecha/lugar de
  entrenamiento con exportación a PDF para el encargado del punto, filtro de
  fecha de aprobación corregido (usa fecha_cumple_requisitos con respaldo en
  fecha_aprobacion), e importación de solicitudes desde el formulario PDF
  S-73 (lectura de campos de AcroForm y prellenado del formulario).
- Corrige bug de zona horaria en formatDateShort (fechas se mostraban un día
  atrás) y bugs de scroll/recorte en el combobox de búsqueda (SearchSelect).

Co-Authored-By: Claude Sonnet 5 <noreply@anthropic.com>
</commit_message>
<xml_diff>
--- a/Diagrama de flujo.pptx
+++ b/Diagrama de flujo.pptx
@@ -8721,6 +8721,36 @@
           <a:chExt cx="0" cy="0"/>
         </a:xfrm>
       </p:grpSpPr>
+      <p:pic>
+        <p:nvPicPr>
+          <p:cNvPr id="3" name="Imagen 2">
+            <a:extLst>
+              <a:ext uri="{FF2B5EF4-FFF2-40B4-BE49-F238E27FC236}">
+                <a16:creationId xmlns:a16="http://schemas.microsoft.com/office/drawing/2014/main" id="{65953968-3EC0-7C7F-5868-FDA784194B79}"/>
+              </a:ext>
+            </a:extLst>
+          </p:cNvPr>
+          <p:cNvPicPr>
+            <a:picLocks noChangeAspect="1"/>
+          </p:cNvPicPr>
+          <p:nvPr/>
+        </p:nvPicPr>
+        <p:blipFill>
+          <a:blip r:embed="rId2"/>
+          <a:stretch>
+            <a:fillRect/>
+          </a:stretch>
+        </p:blipFill>
+        <p:spPr>
+          <a:xfrm>
+            <a:off x="3628331" y="0"/>
+            <a:ext cx="4935338" cy="6858000"/>
+          </a:xfrm>
+          <a:prstGeom prst="rect">
+            <a:avLst/>
+          </a:prstGeom>
+        </p:spPr>
+      </p:pic>
     </p:spTree>
     <p:extLst>
       <p:ext uri="{BB962C8B-B14F-4D97-AF65-F5344CB8AC3E}">
@@ -8757,6 +8787,66 @@
           <a:chExt cx="0" cy="0"/>
         </a:xfrm>
       </p:grpSpPr>
+      <p:pic>
+        <p:nvPicPr>
+          <p:cNvPr id="3" name="Imagen 2">
+            <a:extLst>
+              <a:ext uri="{FF2B5EF4-FFF2-40B4-BE49-F238E27FC236}">
+                <a16:creationId xmlns:a16="http://schemas.microsoft.com/office/drawing/2014/main" id="{E040832E-D071-8D07-4AC7-0A519FFA11E4}"/>
+              </a:ext>
+            </a:extLst>
+          </p:cNvPr>
+          <p:cNvPicPr>
+            <a:picLocks noChangeAspect="1"/>
+          </p:cNvPicPr>
+          <p:nvPr/>
+        </p:nvPicPr>
+        <p:blipFill>
+          <a:blip r:embed="rId2"/>
+          <a:stretch>
+            <a:fillRect/>
+          </a:stretch>
+        </p:blipFill>
+        <p:spPr>
+          <a:xfrm>
+            <a:off x="2391905" y="0"/>
+            <a:ext cx="7408190" cy="6858000"/>
+          </a:xfrm>
+          <a:prstGeom prst="rect">
+            <a:avLst/>
+          </a:prstGeom>
+        </p:spPr>
+      </p:pic>
+      <p:pic>
+        <p:nvPicPr>
+          <p:cNvPr id="5" name="Imagen 4">
+            <a:extLst>
+              <a:ext uri="{FF2B5EF4-FFF2-40B4-BE49-F238E27FC236}">
+                <a16:creationId xmlns:a16="http://schemas.microsoft.com/office/drawing/2014/main" id="{927FE7F7-87F0-8BD0-EA8D-E9F54F9EC605}"/>
+              </a:ext>
+            </a:extLst>
+          </p:cNvPr>
+          <p:cNvPicPr>
+            <a:picLocks noChangeAspect="1"/>
+          </p:cNvPicPr>
+          <p:nvPr/>
+        </p:nvPicPr>
+        <p:blipFill>
+          <a:blip r:embed="rId3"/>
+          <a:stretch>
+            <a:fillRect/>
+          </a:stretch>
+        </p:blipFill>
+        <p:spPr>
+          <a:xfrm>
+            <a:off x="5926330" y="5542927"/>
+            <a:ext cx="1638300" cy="438150"/>
+          </a:xfrm>
+          <a:prstGeom prst="rect">
+            <a:avLst/>
+          </a:prstGeom>
+        </p:spPr>
+      </p:pic>
     </p:spTree>
     <p:extLst>
       <p:ext uri="{BB962C8B-B14F-4D97-AF65-F5344CB8AC3E}">
@@ -8793,6 +8883,118 @@
           <a:chExt cx="0" cy="0"/>
         </a:xfrm>
       </p:grpSpPr>
+      <p:pic>
+        <p:nvPicPr>
+          <p:cNvPr id="3" name="Imagen 2">
+            <a:extLst>
+              <a:ext uri="{FF2B5EF4-FFF2-40B4-BE49-F238E27FC236}">
+                <a16:creationId xmlns:a16="http://schemas.microsoft.com/office/drawing/2014/main" id="{C866B3D7-F93A-856F-7F65-985BF53EC0FA}"/>
+              </a:ext>
+            </a:extLst>
+          </p:cNvPr>
+          <p:cNvPicPr>
+            <a:picLocks noChangeAspect="1"/>
+          </p:cNvPicPr>
+          <p:nvPr/>
+        </p:nvPicPr>
+        <p:blipFill>
+          <a:blip r:embed="rId2"/>
+          <a:stretch>
+            <a:fillRect/>
+          </a:stretch>
+        </p:blipFill>
+        <p:spPr>
+          <a:xfrm>
+            <a:off x="4471212" y="176495"/>
+            <a:ext cx="3249576" cy="6858000"/>
+          </a:xfrm>
+          <a:prstGeom prst="rect">
+            <a:avLst/>
+          </a:prstGeom>
+        </p:spPr>
+      </p:pic>
+      <p:sp>
+        <p:nvSpPr>
+          <p:cNvPr id="4" name="CuadroTexto 3">
+            <a:extLst>
+              <a:ext uri="{FF2B5EF4-FFF2-40B4-BE49-F238E27FC236}">
+                <a16:creationId xmlns:a16="http://schemas.microsoft.com/office/drawing/2014/main" id="{E068BC32-A4D9-478C-023F-39D8A8E08254}"/>
+              </a:ext>
+            </a:extLst>
+          </p:cNvPr>
+          <p:cNvSpPr txBox="1"/>
+          <p:nvPr/>
+        </p:nvSpPr>
+        <p:spPr>
+          <a:xfrm>
+            <a:off x="4471212" y="1313722"/>
+            <a:ext cx="1098378" cy="230832"/>
+          </a:xfrm>
+          <a:prstGeom prst="rect">
+            <a:avLst/>
+          </a:prstGeom>
+          <a:solidFill>
+            <a:srgbClr val="252525"/>
+          </a:solidFill>
+        </p:spPr>
+        <p:txBody>
+          <a:bodyPr wrap="none" rtlCol="0">
+            <a:spAutoFit/>
+          </a:bodyPr>
+          <a:lstStyle/>
+          <a:p>
+            <a:r>
+              <a:rPr lang="es-MX" sz="900" dirty="0">
+                <a:solidFill>
+                  <a:srgbClr val="004E53"/>
+                </a:solidFill>
+              </a:rPr>
+              <a:t>CONFIGURACIÓN</a:t>
+            </a:r>
+            <a:endParaRPr lang="es-CO" sz="900" dirty="0">
+              <a:solidFill>
+                <a:srgbClr val="004E53"/>
+              </a:solidFill>
+            </a:endParaRPr>
+          </a:p>
+        </p:txBody>
+      </p:sp>
+      <p:pic>
+        <p:nvPicPr>
+          <p:cNvPr id="6" name="Imagen 5">
+            <a:extLst>
+              <a:ext uri="{FF2B5EF4-FFF2-40B4-BE49-F238E27FC236}">
+                <a16:creationId xmlns:a16="http://schemas.microsoft.com/office/drawing/2014/main" id="{D56F6B6D-C507-1AE8-C9D0-1F6589556032}"/>
+              </a:ext>
+            </a:extLst>
+          </p:cNvPr>
+          <p:cNvPicPr>
+            <a:picLocks noChangeAspect="1"/>
+          </p:cNvPicPr>
+          <p:nvPr/>
+        </p:nvPicPr>
+        <p:blipFill>
+          <a:blip r:embed="rId3">
+            <a:extLst>
+              <a:ext uri="{28A0092B-C50C-407E-A947-70E740481C1C}">
+                <a14:useLocalDpi xmlns:a14="http://schemas.microsoft.com/office/drawing/2010/main" val="0"/>
+              </a:ext>
+            </a:extLst>
+          </a:blip>
+          <a:stretch>
+            <a:fillRect/>
+          </a:stretch>
+        </p:blipFill>
+        <p:spPr>
+          <a:xfrm>
+            <a:off x="967465" y="0"/>
+            <a:ext cx="4876800" cy="4876800"/>
+          </a:xfrm>
+          <a:prstGeom prst="rect">
+            <a:avLst/>
+          </a:prstGeom>
+        </p:spPr>
+      </p:pic>
     </p:spTree>
     <p:extLst>
       <p:ext uri="{BB962C8B-B14F-4D97-AF65-F5344CB8AC3E}">
@@ -8829,6 +9031,106 @@
           <a:chExt cx="0" cy="0"/>
         </a:xfrm>
       </p:grpSpPr>
+      <p:pic>
+        <p:nvPicPr>
+          <p:cNvPr id="3" name="Imagen 2">
+            <a:extLst>
+              <a:ext uri="{FF2B5EF4-FFF2-40B4-BE49-F238E27FC236}">
+                <a16:creationId xmlns:a16="http://schemas.microsoft.com/office/drawing/2014/main" id="{0103C577-1C14-A7F2-DCC4-D86E4EF71D02}"/>
+              </a:ext>
+            </a:extLst>
+          </p:cNvPr>
+          <p:cNvPicPr>
+            <a:picLocks noChangeAspect="1"/>
+          </p:cNvPicPr>
+          <p:nvPr/>
+        </p:nvPicPr>
+        <p:blipFill>
+          <a:blip r:embed="rId2">
+            <a:extLst>
+              <a:ext uri="{28A0092B-C50C-407E-A947-70E740481C1C}">
+                <a14:useLocalDpi xmlns:a14="http://schemas.microsoft.com/office/drawing/2010/main" val="0"/>
+              </a:ext>
+            </a:extLst>
+          </a:blip>
+          <a:stretch>
+            <a:fillRect/>
+          </a:stretch>
+        </p:blipFill>
+        <p:spPr>
+          <a:xfrm>
+            <a:off x="0" y="0"/>
+            <a:ext cx="10263582" cy="6858000"/>
+          </a:xfrm>
+          <a:prstGeom prst="rect">
+            <a:avLst/>
+          </a:prstGeom>
+        </p:spPr>
+      </p:pic>
+      <p:sp>
+        <p:nvSpPr>
+          <p:cNvPr id="4" name="Rectángulo 3">
+            <a:extLst>
+              <a:ext uri="{FF2B5EF4-FFF2-40B4-BE49-F238E27FC236}">
+                <a16:creationId xmlns:a16="http://schemas.microsoft.com/office/drawing/2014/main" id="{1859DBAD-6F23-E2B5-22D8-07EA7DE634C2}"/>
+              </a:ext>
+            </a:extLst>
+          </p:cNvPr>
+          <p:cNvSpPr/>
+          <p:nvPr/>
+        </p:nvSpPr>
+        <p:spPr>
+          <a:xfrm>
+            <a:off x="7368541" y="3596640"/>
+            <a:ext cx="1973580" cy="454010"/>
+          </a:xfrm>
+          <a:prstGeom prst="rect">
+            <a:avLst/>
+          </a:prstGeom>
+          <a:solidFill>
+            <a:srgbClr val="FAFDFE"/>
+          </a:solidFill>
+          <a:ln>
+            <a:noFill/>
+          </a:ln>
+        </p:spPr>
+        <p:style>
+          <a:lnRef idx="2">
+            <a:schemeClr val="accent1">
+              <a:shade val="15000"/>
+            </a:schemeClr>
+          </a:lnRef>
+          <a:fillRef idx="1">
+            <a:schemeClr val="accent1"/>
+          </a:fillRef>
+          <a:effectRef idx="0">
+            <a:schemeClr val="accent1"/>
+          </a:effectRef>
+          <a:fontRef idx="minor">
+            <a:schemeClr val="lt1"/>
+          </a:fontRef>
+        </p:style>
+        <p:txBody>
+          <a:bodyPr rtlCol="0" anchor="ctr"/>
+          <a:lstStyle/>
+          <a:p>
+            <a:pPr algn="ctr"/>
+            <a:r>
+              <a:rPr lang="es-MX" sz="1100" dirty="0">
+                <a:solidFill>
+                  <a:schemeClr val="tx1"/>
+                </a:solidFill>
+              </a:rPr>
+              <a:t>Predicación Pública de Área Metropolitana</a:t>
+            </a:r>
+            <a:endParaRPr lang="es-CO" sz="1100" dirty="0">
+              <a:solidFill>
+                <a:schemeClr val="tx1"/>
+              </a:solidFill>
+            </a:endParaRPr>
+          </a:p>
+        </p:txBody>
+      </p:sp>
     </p:spTree>
     <p:extLst>
       <p:ext uri="{BB962C8B-B14F-4D97-AF65-F5344CB8AC3E}">

</xml_diff>

<commit_message>
Agrega cambio de contraseña, departamento/municipio en puntos y mejoras de listas
- Menú de cuenta en el header con opciones de cambiar contraseña y cerrar sesión.
- Nuevos campos codigo_departamento/codigo_municipio en la tabla puntos (migración,
  backfill y formulario de alta/edición).
- La lista de chequeo en PDF agrupa por fecha y lugar de entrenamiento, con la fecha,
  dirección completa y encargado del punto en la cabecera de cada sección.
- La columna "Acciones" de las grillas de configuración, mensajes y solicitudes
  se mueve al inicio, con tooltip "Editar registro" en el ícono de edición.
</commit_message>
<xml_diff>
--- a/Diagrama de flujo.pptx
+++ b/Diagrama de flujo.pptx
@@ -269,7 +269,7 @@
           <a:p>
             <a:fld id="{75C10C6A-2B73-494D-B50F-D9E318C2F75F}" type="datetimeFigureOut">
               <a:rPr lang="es-CO" smtClean="0"/>
-              <a:t>13/07/2026</a:t>
+              <a:t>15/07/2026</a:t>
             </a:fld>
             <a:endParaRPr lang="es-CO"/>
           </a:p>
@@ -469,7 +469,7 @@
           <a:p>
             <a:fld id="{75C10C6A-2B73-494D-B50F-D9E318C2F75F}" type="datetimeFigureOut">
               <a:rPr lang="es-CO" smtClean="0"/>
-              <a:t>13/07/2026</a:t>
+              <a:t>15/07/2026</a:t>
             </a:fld>
             <a:endParaRPr lang="es-CO"/>
           </a:p>
@@ -679,7 +679,7 @@
           <a:p>
             <a:fld id="{75C10C6A-2B73-494D-B50F-D9E318C2F75F}" type="datetimeFigureOut">
               <a:rPr lang="es-CO" smtClean="0"/>
-              <a:t>13/07/2026</a:t>
+              <a:t>15/07/2026</a:t>
             </a:fld>
             <a:endParaRPr lang="es-CO"/>
           </a:p>
@@ -879,7 +879,7 @@
           <a:p>
             <a:fld id="{75C10C6A-2B73-494D-B50F-D9E318C2F75F}" type="datetimeFigureOut">
               <a:rPr lang="es-CO" smtClean="0"/>
-              <a:t>13/07/2026</a:t>
+              <a:t>15/07/2026</a:t>
             </a:fld>
             <a:endParaRPr lang="es-CO"/>
           </a:p>
@@ -1155,7 +1155,7 @@
           <a:p>
             <a:fld id="{75C10C6A-2B73-494D-B50F-D9E318C2F75F}" type="datetimeFigureOut">
               <a:rPr lang="es-CO" smtClean="0"/>
-              <a:t>13/07/2026</a:t>
+              <a:t>15/07/2026</a:t>
             </a:fld>
             <a:endParaRPr lang="es-CO"/>
           </a:p>
@@ -1423,7 +1423,7 @@
           <a:p>
             <a:fld id="{75C10C6A-2B73-494D-B50F-D9E318C2F75F}" type="datetimeFigureOut">
               <a:rPr lang="es-CO" smtClean="0"/>
-              <a:t>13/07/2026</a:t>
+              <a:t>15/07/2026</a:t>
             </a:fld>
             <a:endParaRPr lang="es-CO"/>
           </a:p>
@@ -1838,7 +1838,7 @@
           <a:p>
             <a:fld id="{75C10C6A-2B73-494D-B50F-D9E318C2F75F}" type="datetimeFigureOut">
               <a:rPr lang="es-CO" smtClean="0"/>
-              <a:t>13/07/2026</a:t>
+              <a:t>15/07/2026</a:t>
             </a:fld>
             <a:endParaRPr lang="es-CO"/>
           </a:p>
@@ -1980,7 +1980,7 @@
           <a:p>
             <a:fld id="{75C10C6A-2B73-494D-B50F-D9E318C2F75F}" type="datetimeFigureOut">
               <a:rPr lang="es-CO" smtClean="0"/>
-              <a:t>13/07/2026</a:t>
+              <a:t>15/07/2026</a:t>
             </a:fld>
             <a:endParaRPr lang="es-CO"/>
           </a:p>
@@ -2093,7 +2093,7 @@
           <a:p>
             <a:fld id="{75C10C6A-2B73-494D-B50F-D9E318C2F75F}" type="datetimeFigureOut">
               <a:rPr lang="es-CO" smtClean="0"/>
-              <a:t>13/07/2026</a:t>
+              <a:t>15/07/2026</a:t>
             </a:fld>
             <a:endParaRPr lang="es-CO"/>
           </a:p>
@@ -2406,7 +2406,7 @@
           <a:p>
             <a:fld id="{75C10C6A-2B73-494D-B50F-D9E318C2F75F}" type="datetimeFigureOut">
               <a:rPr lang="es-CO" smtClean="0"/>
-              <a:t>13/07/2026</a:t>
+              <a:t>15/07/2026</a:t>
             </a:fld>
             <a:endParaRPr lang="es-CO"/>
           </a:p>
@@ -2695,7 +2695,7 @@
           <a:p>
             <a:fld id="{75C10C6A-2B73-494D-B50F-D9E318C2F75F}" type="datetimeFigureOut">
               <a:rPr lang="es-CO" smtClean="0"/>
-              <a:t>13/07/2026</a:t>
+              <a:t>15/07/2026</a:t>
             </a:fld>
             <a:endParaRPr lang="es-CO"/>
           </a:p>
@@ -2938,7 +2938,7 @@
           <a:p>
             <a:fld id="{75C10C6A-2B73-494D-B50F-D9E318C2F75F}" type="datetimeFigureOut">
               <a:rPr lang="es-CO" smtClean="0"/>
-              <a:t>13/07/2026</a:t>
+              <a:t>15/07/2026</a:t>
             </a:fld>
             <a:endParaRPr lang="es-CO"/>
           </a:p>
@@ -9167,6 +9167,314 @@
           <a:chExt cx="0" cy="0"/>
         </a:xfrm>
       </p:grpSpPr>
+      <p:pic>
+        <p:nvPicPr>
+          <p:cNvPr id="3" name="Imagen 2">
+            <a:extLst>
+              <a:ext uri="{FF2B5EF4-FFF2-40B4-BE49-F238E27FC236}">
+                <a16:creationId xmlns:a16="http://schemas.microsoft.com/office/drawing/2014/main" id="{5B268BBB-C244-649E-96C1-CFC88D96A3AD}"/>
+              </a:ext>
+            </a:extLst>
+          </p:cNvPr>
+          <p:cNvPicPr>
+            <a:picLocks noChangeAspect="1"/>
+          </p:cNvPicPr>
+          <p:nvPr/>
+        </p:nvPicPr>
+        <p:blipFill>
+          <a:blip r:embed="rId2"/>
+          <a:stretch>
+            <a:fillRect/>
+          </a:stretch>
+        </p:blipFill>
+        <p:spPr>
+          <a:xfrm>
+            <a:off x="371475" y="374985"/>
+            <a:ext cx="3829050" cy="1905000"/>
+          </a:xfrm>
+          <a:prstGeom prst="rect">
+            <a:avLst/>
+          </a:prstGeom>
+        </p:spPr>
+      </p:pic>
+      <p:sp>
+        <p:nvSpPr>
+          <p:cNvPr id="5" name="Rectángulo 4">
+            <a:extLst>
+              <a:ext uri="{FF2B5EF4-FFF2-40B4-BE49-F238E27FC236}">
+                <a16:creationId xmlns:a16="http://schemas.microsoft.com/office/drawing/2014/main" id="{9932CC4A-B4B7-B23D-CCFA-F912A4CE0667}"/>
+              </a:ext>
+            </a:extLst>
+          </p:cNvPr>
+          <p:cNvSpPr/>
+          <p:nvPr/>
+        </p:nvSpPr>
+        <p:spPr>
+          <a:xfrm>
+            <a:off x="4118810" y="3033214"/>
+            <a:ext cx="409074" cy="393032"/>
+          </a:xfrm>
+          <a:prstGeom prst="rect">
+            <a:avLst/>
+          </a:prstGeom>
+          <a:solidFill>
+            <a:srgbClr val="FFFFFF"/>
+          </a:solidFill>
+        </p:spPr>
+        <p:style>
+          <a:lnRef idx="2">
+            <a:schemeClr val="accent1">
+              <a:shade val="15000"/>
+            </a:schemeClr>
+          </a:lnRef>
+          <a:fillRef idx="1">
+            <a:schemeClr val="accent1"/>
+          </a:fillRef>
+          <a:effectRef idx="0">
+            <a:schemeClr val="accent1"/>
+          </a:effectRef>
+          <a:fontRef idx="minor">
+            <a:schemeClr val="lt1"/>
+          </a:fontRef>
+        </p:style>
+        <p:txBody>
+          <a:bodyPr rtlCol="0" anchor="ctr"/>
+          <a:lstStyle/>
+          <a:p>
+            <a:pPr algn="ctr"/>
+            <a:endParaRPr lang="es-CO"/>
+          </a:p>
+        </p:txBody>
+      </p:sp>
+      <p:sp>
+        <p:nvSpPr>
+          <p:cNvPr id="6" name="Rectángulo 5">
+            <a:extLst>
+              <a:ext uri="{FF2B5EF4-FFF2-40B4-BE49-F238E27FC236}">
+                <a16:creationId xmlns:a16="http://schemas.microsoft.com/office/drawing/2014/main" id="{32A77998-22A2-329A-95AE-773F6DB100BA}"/>
+              </a:ext>
+            </a:extLst>
+          </p:cNvPr>
+          <p:cNvSpPr/>
+          <p:nvPr/>
+        </p:nvSpPr>
+        <p:spPr>
+          <a:xfrm>
+            <a:off x="4118810" y="3730523"/>
+            <a:ext cx="409074" cy="393032"/>
+          </a:xfrm>
+          <a:prstGeom prst="rect">
+            <a:avLst/>
+          </a:prstGeom>
+          <a:solidFill>
+            <a:srgbClr val="F0EDED"/>
+          </a:solidFill>
+        </p:spPr>
+        <p:style>
+          <a:lnRef idx="2">
+            <a:schemeClr val="accent1">
+              <a:shade val="15000"/>
+            </a:schemeClr>
+          </a:lnRef>
+          <a:fillRef idx="1">
+            <a:schemeClr val="accent1"/>
+          </a:fillRef>
+          <a:effectRef idx="0">
+            <a:schemeClr val="accent1"/>
+          </a:effectRef>
+          <a:fontRef idx="minor">
+            <a:schemeClr val="lt1"/>
+          </a:fontRef>
+        </p:style>
+        <p:txBody>
+          <a:bodyPr rtlCol="0" anchor="ctr"/>
+          <a:lstStyle/>
+          <a:p>
+            <a:pPr algn="ctr"/>
+            <a:endParaRPr lang="es-CO"/>
+          </a:p>
+        </p:txBody>
+      </p:sp>
+      <p:sp>
+        <p:nvSpPr>
+          <p:cNvPr id="9" name="CuadroTexto 8">
+            <a:extLst>
+              <a:ext uri="{FF2B5EF4-FFF2-40B4-BE49-F238E27FC236}">
+                <a16:creationId xmlns:a16="http://schemas.microsoft.com/office/drawing/2014/main" id="{9B65F8FA-C44F-FB6F-7F5E-2EFDB3EB688C}"/>
+              </a:ext>
+            </a:extLst>
+          </p:cNvPr>
+          <p:cNvSpPr txBox="1"/>
+          <p:nvPr/>
+        </p:nvSpPr>
+        <p:spPr>
+          <a:xfrm>
+            <a:off x="5954383" y="649342"/>
+            <a:ext cx="1585104" cy="369332"/>
+          </a:xfrm>
+          <a:prstGeom prst="rect">
+            <a:avLst/>
+          </a:prstGeom>
+          <a:noFill/>
+        </p:spPr>
+        <p:txBody>
+          <a:bodyPr wrap="square">
+            <a:spAutoFit/>
+          </a:bodyPr>
+          <a:lstStyle/>
+          <a:p>
+            <a:r>
+              <a:rPr lang="es-CO" dirty="0"/>
+              <a:t>#FFFFFF</a:t>
+            </a:r>
+          </a:p>
+        </p:txBody>
+      </p:sp>
+      <p:cxnSp>
+        <p:nvCxnSpPr>
+          <p:cNvPr id="11" name="Conector recto de flecha 10">
+            <a:extLst>
+              <a:ext uri="{FF2B5EF4-FFF2-40B4-BE49-F238E27FC236}">
+                <a16:creationId xmlns:a16="http://schemas.microsoft.com/office/drawing/2014/main" id="{FCC00436-5718-7B9B-213F-1BE0DCE8E4A0}"/>
+              </a:ext>
+            </a:extLst>
+          </p:cNvPr>
+          <p:cNvCxnSpPr>
+            <a:endCxn id="9" idx="1"/>
+          </p:cNvCxnSpPr>
+          <p:nvPr/>
+        </p:nvCxnSpPr>
+        <p:spPr>
+          <a:xfrm>
+            <a:off x="3847381" y="834008"/>
+            <a:ext cx="2107002" cy="0"/>
+          </a:xfrm>
+          <a:prstGeom prst="straightConnector1">
+            <a:avLst/>
+          </a:prstGeom>
+          <a:ln>
+            <a:tailEnd type="triangle"/>
+          </a:ln>
+        </p:spPr>
+        <p:style>
+          <a:lnRef idx="2">
+            <a:schemeClr val="accent1"/>
+          </a:lnRef>
+          <a:fillRef idx="0">
+            <a:schemeClr val="accent1"/>
+          </a:fillRef>
+          <a:effectRef idx="1">
+            <a:schemeClr val="accent1"/>
+          </a:effectRef>
+          <a:fontRef idx="minor">
+            <a:schemeClr val="tx1"/>
+          </a:fontRef>
+        </p:style>
+      </p:cxnSp>
+      <p:pic>
+        <p:nvPicPr>
+          <p:cNvPr id="14" name="Imagen 13">
+            <a:extLst>
+              <a:ext uri="{FF2B5EF4-FFF2-40B4-BE49-F238E27FC236}">
+                <a16:creationId xmlns:a16="http://schemas.microsoft.com/office/drawing/2014/main" id="{703FF2BF-BC1E-D8A5-84F0-B05BFF069705}"/>
+              </a:ext>
+            </a:extLst>
+          </p:cNvPr>
+          <p:cNvPicPr>
+            <a:picLocks noChangeAspect="1"/>
+          </p:cNvPicPr>
+          <p:nvPr/>
+        </p:nvPicPr>
+        <p:blipFill>
+          <a:blip r:embed="rId3"/>
+          <a:stretch>
+            <a:fillRect/>
+          </a:stretch>
+        </p:blipFill>
+        <p:spPr>
+          <a:xfrm>
+            <a:off x="456197" y="4504504"/>
+            <a:ext cx="3867150" cy="1943100"/>
+          </a:xfrm>
+          <a:prstGeom prst="rect">
+            <a:avLst/>
+          </a:prstGeom>
+        </p:spPr>
+      </p:pic>
+      <p:sp>
+        <p:nvSpPr>
+          <p:cNvPr id="8" name="CuadroTexto 7">
+            <a:extLst>
+              <a:ext uri="{FF2B5EF4-FFF2-40B4-BE49-F238E27FC236}">
+                <a16:creationId xmlns:a16="http://schemas.microsoft.com/office/drawing/2014/main" id="{90E46FE0-DDEC-BFE7-865E-C78B830E1095}"/>
+              </a:ext>
+            </a:extLst>
+          </p:cNvPr>
+          <p:cNvSpPr txBox="1"/>
+          <p:nvPr/>
+        </p:nvSpPr>
+        <p:spPr>
+          <a:xfrm>
+            <a:off x="5376848" y="5839326"/>
+            <a:ext cx="3867150" cy="923330"/>
+          </a:xfrm>
+          <a:prstGeom prst="rect">
+            <a:avLst/>
+          </a:prstGeom>
+          <a:noFill/>
+        </p:spPr>
+        <p:txBody>
+          <a:bodyPr wrap="square">
+            <a:spAutoFit/>
+          </a:bodyPr>
+          <a:lstStyle/>
+          <a:p>
+            <a:r>
+              <a:rPr lang="es-CO" dirty="0"/>
+              <a:t>Esta zona debe ser color de fondo #F0EDED cuando el filtro no esté seleccionado.</a:t>
+            </a:r>
+          </a:p>
+        </p:txBody>
+      </p:sp>
+      <p:cxnSp>
+        <p:nvCxnSpPr>
+          <p:cNvPr id="12" name="Conector recto de flecha 11">
+            <a:extLst>
+              <a:ext uri="{FF2B5EF4-FFF2-40B4-BE49-F238E27FC236}">
+                <a16:creationId xmlns:a16="http://schemas.microsoft.com/office/drawing/2014/main" id="{BBD0F928-A207-3817-86F6-138FCA8F4A10}"/>
+              </a:ext>
+            </a:extLst>
+          </p:cNvPr>
+          <p:cNvCxnSpPr/>
+          <p:nvPr/>
+        </p:nvCxnSpPr>
+        <p:spPr>
+          <a:xfrm>
+            <a:off x="3269846" y="6023992"/>
+            <a:ext cx="2107002" cy="0"/>
+          </a:xfrm>
+          <a:prstGeom prst="straightConnector1">
+            <a:avLst/>
+          </a:prstGeom>
+          <a:ln>
+            <a:tailEnd type="triangle"/>
+          </a:ln>
+        </p:spPr>
+        <p:style>
+          <a:lnRef idx="2">
+            <a:schemeClr val="accent1"/>
+          </a:lnRef>
+          <a:fillRef idx="0">
+            <a:schemeClr val="accent1"/>
+          </a:fillRef>
+          <a:effectRef idx="1">
+            <a:schemeClr val="accent1"/>
+          </a:effectRef>
+          <a:fontRef idx="minor">
+            <a:schemeClr val="tx1"/>
+          </a:fontRef>
+        </p:style>
+      </p:cxnSp>
     </p:spTree>
     <p:extLst>
       <p:ext uri="{BB962C8B-B14F-4D97-AF65-F5344CB8AC3E}">

</xml_diff>